<commit_message>
presentations: PPTX bullets as real list formatting
Replace the literal bullet-prefix runs with a:buChar list formatting
per paragraph (accent-colored bullet, hanging indent), so wrapped
lines align under the text and Google Slides treats the paragraphs
as proper lists.

Co-Authored-By: Claude Fable 5 <noreply@anthropic.com>
</commit_message>
<xml_diff>
--- a/presentations/2026-08-17-dtaas.pptx
+++ b/presentations/2026-08-17-dtaas.pptx
@@ -4314,31 +4314,45 @@
           </a:bodyPr>
           <a:lstStyle/>
           <a:p>
-            <a:pPr>
+            <a:pPr marL="256032" indent="-256032">
               <a:lnSpc>
                 <a:spcPct val="115000"/>
               </a:lnSpc>
               <a:spcAft>
                 <a:spcPts val="1000"/>
               </a:spcAft>
+              <a:buClr>
+                <a:srgbClr val="0B5FA5"/>
+              </a:buClr>
+              <a:buFont typeface="Arial"/>
+              <a:buChar char="▸"/>
             </a:pPr>
             <a:r>
+              <a:rPr sz="1300" b="1">
+                <a:solidFill>
+                  <a:srgbClr val="0B5FA5"/>
+                </a:solidFill>
+                <a:latin typeface="Arial"/>
+              </a:rPr>
+              <a:t>126 tests</a:t>
+            </a:r>
+            <a:r>
               <a:rPr sz="1300">
                 <a:solidFill>
-                  <a:srgbClr val="0B5FA5"/>
-                </a:solidFill>
-                <a:latin typeface="Arial"/>
-              </a:rPr>
-              <a:t>▸  </a:t>
+                  <a:srgbClr val="1A2330"/>
+                </a:solidFill>
+                <a:latin typeface="Arial"/>
+              </a:rPr>
+              <a:t>, including live-broker integration. Demos verified with both stream backends: service DT and streaming learner; </a:t>
             </a:r>
             <a:r>
               <a:rPr sz="1300" b="1">
                 <a:solidFill>
-                  <a:srgbClr val="0B5FA5"/>
-                </a:solidFill>
-                <a:latin typeface="Arial"/>
-              </a:rPr>
-              <a:t>126 tests</a:t>
+                  <a:srgbClr val="B3541E"/>
+                </a:solidFill>
+                <a:latin typeface="Arial"/>
+              </a:rPr>
+              <a:t>calibration converges</a:t>
             </a:r>
             <a:r>
               <a:rPr sz="1300">
@@ -4347,44 +4361,40 @@
                 </a:solidFill>
                 <a:latin typeface="Arial"/>
               </a:rPr>
-              <a:t>, including live-broker integration. Demos verified with both stream backends: service DT and streaming learner; </a:t>
-            </a:r>
-            <a:r>
-              <a:rPr sz="1300" b="1">
-                <a:solidFill>
-                  <a:srgbClr val="B3541E"/>
-                </a:solidFill>
-                <a:latin typeface="Arial"/>
-              </a:rPr>
-              <a:t>calibration converges</a:t>
-            </a:r>
-            <a:r>
-              <a:rPr sz="1300">
-                <a:solidFill>
-                  <a:srgbClr val="1A2330"/>
-                </a:solidFill>
-                <a:latin typeface="Arial"/>
-              </a:rPr>
               <a:t>.</a:t>
             </a:r>
           </a:p>
           <a:p>
-            <a:pPr>
+            <a:pPr marL="256032" indent="-256032">
               <a:lnSpc>
                 <a:spcPct val="115000"/>
               </a:lnSpc>
               <a:spcAft>
                 <a:spcPts val="1000"/>
               </a:spcAft>
+              <a:buClr>
+                <a:srgbClr val="0B5FA5"/>
+              </a:buClr>
+              <a:buFont typeface="Arial"/>
+              <a:buChar char="▸"/>
             </a:pPr>
             <a:r>
               <a:rPr sz="1300">
                 <a:solidFill>
+                  <a:srgbClr val="1A2330"/>
+                </a:solidFill>
+                <a:latin typeface="Arial"/>
+              </a:rPr>
+              <a:t>Upstream: two ORBIT PRs </a:t>
+            </a:r>
+            <a:r>
+              <a:rPr sz="1300" b="1">
+                <a:solidFill>
                   <a:srgbClr val="0B5FA5"/>
                 </a:solidFill>
                 <a:latin typeface="Arial"/>
               </a:rPr>
-              <a:t>▸  </a:t>
+              <a:t>merged</a:t>
             </a:r>
             <a:r>
               <a:rPr sz="1300">
@@ -4393,45 +4403,23 @@
                 </a:solidFill>
                 <a:latin typeface="Arial"/>
               </a:rPr>
-              <a:t>Upstream: two ORBIT PRs </a:t>
-            </a:r>
-            <a:r>
-              <a:rPr sz="1300" b="1">
-                <a:solidFill>
-                  <a:srgbClr val="0B5FA5"/>
-                </a:solidFill>
-                <a:latin typeface="Arial"/>
-              </a:rPr>
-              <a:t>merged</a:t>
-            </a:r>
-            <a:r>
-              <a:rPr sz="1300">
-                <a:solidFill>
-                  <a:srgbClr val="1A2330"/>
-                </a:solidFill>
-                <a:latin typeface="Arial"/>
-              </a:rPr>
               <a:t>; one AsyncFlow fix + one ROSE dependency in review.</a:t>
             </a:r>
           </a:p>
           <a:p>
-            <a:pPr>
+            <a:pPr marL="256032" indent="-256032">
               <a:lnSpc>
                 <a:spcPct val="115000"/>
               </a:lnSpc>
               <a:spcAft>
                 <a:spcPts val="1000"/>
               </a:spcAft>
+              <a:buClr>
+                <a:srgbClr val="0B5FA5"/>
+              </a:buClr>
+              <a:buFont typeface="Arial"/>
+              <a:buChar char="▸"/>
             </a:pPr>
-            <a:r>
-              <a:rPr sz="1300">
-                <a:solidFill>
-                  <a:srgbClr val="0B5FA5"/>
-                </a:solidFill>
-                <a:latin typeface="Arial"/>
-              </a:rPr>
-              <a:t>▸  </a:t>
-            </a:r>
             <a:r>
               <a:rPr sz="1300">
                 <a:solidFill>
@@ -5632,22 +5620,36 @@
           </a:bodyPr>
           <a:lstStyle/>
           <a:p>
-            <a:pPr>
+            <a:pPr marL="256032" indent="-256032">
               <a:lnSpc>
                 <a:spcPct val="115000"/>
               </a:lnSpc>
               <a:spcAft>
                 <a:spcPts val="1000"/>
               </a:spcAft>
+              <a:buClr>
+                <a:srgbClr val="0B5FA5"/>
+              </a:buClr>
+              <a:buFont typeface="Arial"/>
+              <a:buChar char="▸"/>
             </a:pPr>
             <a:r>
               <a:rPr sz="1600">
                 <a:solidFill>
-                  <a:srgbClr val="0B5FA5"/>
-                </a:solidFill>
-                <a:latin typeface="Arial"/>
-              </a:rPr>
-              <a:t>▸  </a:t>
+                  <a:srgbClr val="1A2330"/>
+                </a:solidFill>
+                <a:latin typeface="Arial"/>
+              </a:rPr>
+              <a:t>A digital twin is a computational counterpart of a physical system: its models </a:t>
+            </a:r>
+            <a:r>
+              <a:rPr sz="1600" b="1">
+                <a:solidFill>
+                  <a:srgbClr val="B3541E"/>
+                </a:solidFill>
+                <a:latin typeface="Arial"/>
+              </a:rPr>
+              <a:t>keep learning</a:t>
             </a:r>
             <a:r>
               <a:rPr sz="1600">
@@ -5656,7 +5658,7 @@
                 </a:solidFill>
                 <a:latin typeface="Arial"/>
               </a:rPr>
-              <a:t>A digital twin is a computational counterpart of a physical system: its models </a:t>
+              <a:t> against reality while </a:t>
             </a:r>
             <a:r>
               <a:rPr sz="1600" b="1">
@@ -5665,7 +5667,7 @@
                 </a:solidFill>
                 <a:latin typeface="Arial"/>
               </a:rPr>
-              <a:t>keep learning</a:t>
+              <a:t>serving inference</a:t>
             </a:r>
             <a:r>
               <a:rPr sz="1600">
@@ -5674,44 +5676,40 @@
                 </a:solidFill>
                 <a:latin typeface="Arial"/>
               </a:rPr>
-              <a:t> against reality while </a:t>
-            </a:r>
-            <a:r>
-              <a:rPr sz="1600" b="1">
-                <a:solidFill>
-                  <a:srgbClr val="B3541E"/>
-                </a:solidFill>
-                <a:latin typeface="Arial"/>
-              </a:rPr>
-              <a:t>serving inference</a:t>
-            </a:r>
-            <a:r>
-              <a:rPr sz="1600">
-                <a:solidFill>
-                  <a:srgbClr val="1A2330"/>
-                </a:solidFill>
-                <a:latin typeface="Arial"/>
-              </a:rPr>
               <a:t>.</a:t>
             </a:r>
           </a:p>
           <a:p>
-            <a:pPr>
+            <a:pPr marL="256032" indent="-256032">
               <a:lnSpc>
                 <a:spcPct val="115000"/>
               </a:lnSpc>
               <a:spcAft>
                 <a:spcPts val="1000"/>
               </a:spcAft>
+              <a:buClr>
+                <a:srgbClr val="0B5FA5"/>
+              </a:buClr>
+              <a:buFont typeface="Arial"/>
+              <a:buChar char="▸"/>
             </a:pPr>
             <a:r>
               <a:rPr sz="1600">
                 <a:solidFill>
+                  <a:srgbClr val="1A2330"/>
+                </a:solidFill>
+                <a:latin typeface="Arial"/>
+              </a:rPr>
+              <a:t>The DT is a </a:t>
+            </a:r>
+            <a:r>
+              <a:rPr sz="1600" b="1">
+                <a:solidFill>
                   <a:srgbClr val="0B5FA5"/>
                 </a:solidFill>
                 <a:latin typeface="Arial"/>
               </a:rPr>
-              <a:t>▸  </a:t>
+              <a:t>graph of capabilities</a:t>
             </a:r>
             <a:r>
               <a:rPr sz="1600">
@@ -5720,44 +5718,40 @@
                 </a:solidFill>
                 <a:latin typeface="Arial"/>
               </a:rPr>
-              <a:t>The DT is a </a:t>
-            </a:r>
-            <a:r>
-              <a:rPr sz="1600" b="1">
-                <a:solidFill>
-                  <a:srgbClr val="0B5FA5"/>
-                </a:solidFill>
-                <a:latin typeface="Arial"/>
-              </a:rPr>
-              <a:t>graph of capabilities</a:t>
-            </a:r>
-            <a:r>
-              <a:rPr sz="1600">
-                <a:solidFill>
-                  <a:srgbClr val="1A2330"/>
-                </a:solidFill>
-                <a:latin typeface="Arial"/>
-              </a:rPr>
               <a:t>: typed input → output contracts (e.g. diagnostics → heat flux), each realized by one or more learned models.</a:t>
             </a:r>
           </a:p>
           <a:p>
-            <a:pPr>
+            <a:pPr marL="256032" indent="-256032">
               <a:lnSpc>
                 <a:spcPct val="115000"/>
               </a:lnSpc>
               <a:spcAft>
                 <a:spcPts val="1000"/>
               </a:spcAft>
+              <a:buClr>
+                <a:srgbClr val="0B5FA5"/>
+              </a:buClr>
+              <a:buFont typeface="Arial"/>
+              <a:buChar char="▸"/>
             </a:pPr>
             <a:r>
               <a:rPr sz="1600">
                 <a:solidFill>
+                  <a:srgbClr val="1A2330"/>
+                </a:solidFill>
+                <a:latin typeface="Arial"/>
+              </a:rPr>
+              <a:t>Two concurrent loops: </a:t>
+            </a:r>
+            <a:r>
+              <a:rPr sz="1600" b="1">
+                <a:solidFill>
                   <a:srgbClr val="0B5FA5"/>
                 </a:solidFill>
                 <a:latin typeface="Arial"/>
               </a:rPr>
-              <a:t>▸  </a:t>
+              <a:t>learning</a:t>
             </a:r>
             <a:r>
               <a:rPr sz="1600">
@@ -5766,7 +5760,7 @@
                 </a:solidFill>
                 <a:latin typeface="Arial"/>
               </a:rPr>
-              <a:t>Two concurrent loops: </a:t>
+              <a:t> runs until its objective is met and restarts on new data; </a:t>
             </a:r>
             <a:r>
               <a:rPr sz="1600" b="1">
@@ -5775,7 +5769,7 @@
                 </a:solidFill>
                 <a:latin typeface="Arial"/>
               </a:rPr>
-              <a:t>learning</a:t>
+              <a:t>inference</a:t>
             </a:r>
             <a:r>
               <a:rPr sz="1600">
@@ -5784,45 +5778,23 @@
                 </a:solidFill>
                 <a:latin typeface="Arial"/>
               </a:rPr>
-              <a:t> runs until its objective is met and restarts on new data; </a:t>
-            </a:r>
-            <a:r>
-              <a:rPr sz="1600" b="1">
-                <a:solidFill>
-                  <a:srgbClr val="0B5FA5"/>
-                </a:solidFill>
-                <a:latin typeface="Arial"/>
-              </a:rPr>
-              <a:t>inference</a:t>
-            </a:r>
-            <a:r>
-              <a:rPr sz="1600">
-                <a:solidFill>
-                  <a:srgbClr val="1A2330"/>
-                </a:solidFill>
-                <a:latin typeface="Arial"/>
-              </a:rPr>
               <a:t> runs indefinitely and hot-swaps models as they improve.</a:t>
             </a:r>
           </a:p>
           <a:p>
-            <a:pPr>
+            <a:pPr marL="256032" indent="-256032">
               <a:lnSpc>
                 <a:spcPct val="115000"/>
               </a:lnSpc>
               <a:spcAft>
                 <a:spcPts val="1000"/>
               </a:spcAft>
+              <a:buClr>
+                <a:srgbClr val="0B5FA5"/>
+              </a:buClr>
+              <a:buFont typeface="Arial"/>
+              <a:buChar char="▸"/>
             </a:pPr>
-            <a:r>
-              <a:rPr sz="1600">
-                <a:solidFill>
-                  <a:srgbClr val="0B5FA5"/>
-                </a:solidFill>
-                <a:latin typeface="Arial"/>
-              </a:rPr>
-              <a:t>▸  </a:t>
-            </a:r>
             <a:r>
               <a:rPr sz="1600">
                 <a:solidFill>
@@ -6022,22 +5994,36 @@
           </a:bodyPr>
           <a:lstStyle/>
           <a:p>
-            <a:pPr>
+            <a:pPr marL="256032" indent="-256032">
               <a:lnSpc>
                 <a:spcPct val="115000"/>
               </a:lnSpc>
               <a:spcAft>
                 <a:spcPts val="1000"/>
               </a:spcAft>
+              <a:buClr>
+                <a:srgbClr val="0B5FA5"/>
+              </a:buClr>
+              <a:buFont typeface="Arial"/>
+              <a:buChar char="▸"/>
             </a:pPr>
             <a:r>
               <a:rPr sz="1500">
                 <a:solidFill>
+                  <a:srgbClr val="1A2330"/>
+                </a:solidFill>
+                <a:latin typeface="Arial"/>
+              </a:rPr>
+              <a:t>The DT control plane runs as a plugin on a </a:t>
+            </a:r>
+            <a:r>
+              <a:rPr sz="1500" b="1">
+                <a:solidFill>
                   <a:srgbClr val="0B5FA5"/>
                 </a:solidFill>
                 <a:latin typeface="Arial"/>
               </a:rPr>
-              <a:t>▸  </a:t>
+              <a:t>persistent ORBIT broker</a:t>
             </a:r>
             <a:r>
               <a:rPr sz="1500">
@@ -6046,44 +6032,40 @@
                 </a:solidFill>
                 <a:latin typeface="Arial"/>
               </a:rPr>
-              <a:t>The DT control plane runs as a plugin on a </a:t>
-            </a:r>
-            <a:r>
-              <a:rPr sz="1500" b="1">
-                <a:solidFill>
-                  <a:srgbClr val="0B5FA5"/>
-                </a:solidFill>
-                <a:latin typeface="Arial"/>
-              </a:rPr>
-              <a:t>persistent ORBIT broker</a:t>
-            </a:r>
-            <a:r>
-              <a:rPr sz="1500">
-                <a:solidFill>
-                  <a:srgbClr val="1A2330"/>
-                </a:solidFill>
-                <a:latin typeface="Arial"/>
-              </a:rPr>
               <a:t>; the DT runs for months, independent of any login session.</a:t>
             </a:r>
           </a:p>
           <a:p>
-            <a:pPr>
+            <a:pPr marL="256032" indent="-256032">
               <a:lnSpc>
                 <a:spcPct val="115000"/>
               </a:lnSpc>
               <a:spcAft>
                 <a:spcPts val="1000"/>
               </a:spcAft>
+              <a:buClr>
+                <a:srgbClr val="0B5FA5"/>
+              </a:buClr>
+              <a:buFont typeface="Arial"/>
+              <a:buChar char="▸"/>
             </a:pPr>
             <a:r>
               <a:rPr sz="1500">
                 <a:solidFill>
+                  <a:srgbClr val="1A2330"/>
+                </a:solidFill>
+                <a:latin typeface="Arial"/>
+              </a:rPr>
+              <a:t>Scientists </a:t>
+            </a:r>
+            <a:r>
+              <a:rPr sz="1500" b="1">
+                <a:solidFill>
                   <a:srgbClr val="0B5FA5"/>
                 </a:solidFill>
                 <a:latin typeface="Arial"/>
               </a:rPr>
-              <a:t>▸  </a:t>
+              <a:t>attach from a laptop</a:t>
             </a:r>
             <a:r>
               <a:rPr sz="1500">
@@ -6092,44 +6074,40 @@
                 </a:solidFill>
                 <a:latin typeface="Arial"/>
               </a:rPr>
-              <a:t>Scientists </a:t>
-            </a:r>
-            <a:r>
-              <a:rPr sz="1500" b="1">
-                <a:solidFill>
-                  <a:srgbClr val="0B5FA5"/>
-                </a:solidFill>
-                <a:latin typeface="Arial"/>
-              </a:rPr>
-              <a:t>attach from a laptop</a:t>
-            </a:r>
-            <a:r>
-              <a:rPr sz="1500">
-                <a:solidFill>
-                  <a:srgbClr val="1A2330"/>
-                </a:solidFill>
-                <a:latin typeface="Arial"/>
-              </a:rPr>
               <a:t>, steer, and detach; the DT keeps running. Reattach later, from anywhere.</a:t>
             </a:r>
           </a:p>
           <a:p>
-            <a:pPr>
+            <a:pPr marL="256032" indent="-256032">
               <a:lnSpc>
                 <a:spcPct val="115000"/>
               </a:lnSpc>
               <a:spcAft>
                 <a:spcPts val="1000"/>
               </a:spcAft>
+              <a:buClr>
+                <a:srgbClr val="0B5FA5"/>
+              </a:buClr>
+              <a:buFont typeface="Arial"/>
+              <a:buChar char="▸"/>
             </a:pPr>
             <a:r>
               <a:rPr sz="1500">
                 <a:solidFill>
+                  <a:srgbClr val="1A2330"/>
+                </a:solidFill>
+                <a:latin typeface="Arial"/>
+              </a:rPr>
+              <a:t>One broker hosts </a:t>
+            </a:r>
+            <a:r>
+              <a:rPr sz="1500" b="1">
+                <a:solidFill>
                   <a:srgbClr val="0B5FA5"/>
                 </a:solidFill>
                 <a:latin typeface="Arial"/>
               </a:rPr>
-              <a:t>▸  </a:t>
+              <a:t>multiple sessions</a:t>
             </a:r>
             <a:r>
               <a:rPr sz="1500">
@@ -6138,7 +6116,7 @@
                 </a:solidFill>
                 <a:latin typeface="Arial"/>
               </a:rPr>
-              <a:t>One broker hosts </a:t>
+              <a:t> (name spaces); each session holds </a:t>
             </a:r>
             <a:r>
               <a:rPr sz="1500" b="1">
@@ -6147,7 +6125,7 @@
                 </a:solidFill>
                 <a:latin typeface="Arial"/>
               </a:rPr>
-              <a:t>multiple sessions</a:t>
+              <a:t>multiple DTs</a:t>
             </a:r>
             <a:r>
               <a:rPr sz="1500">
@@ -6156,44 +6134,40 @@
                 </a:solidFill>
                 <a:latin typeface="Arial"/>
               </a:rPr>
-              <a:t> (name spaces); each session holds </a:t>
-            </a:r>
-            <a:r>
-              <a:rPr sz="1500" b="1">
-                <a:solidFill>
-                  <a:srgbClr val="0B5FA5"/>
-                </a:solidFill>
-                <a:latin typeface="Arial"/>
-              </a:rPr>
-              <a:t>multiple DTs</a:t>
-            </a:r>
-            <a:r>
-              <a:rPr sz="1500">
-                <a:solidFill>
-                  <a:srgbClr val="1A2330"/>
-                </a:solidFill>
-                <a:latin typeface="Arial"/>
-              </a:rPr>
               <a:t>.</a:t>
             </a:r>
           </a:p>
           <a:p>
-            <a:pPr>
+            <a:pPr marL="256032" indent="-256032">
               <a:lnSpc>
                 <a:spcPct val="115000"/>
               </a:lnSpc>
               <a:spcAft>
                 <a:spcPts val="1000"/>
               </a:spcAft>
+              <a:buClr>
+                <a:srgbClr val="0B5FA5"/>
+              </a:buClr>
+              <a:buFont typeface="Arial"/>
+              <a:buChar char="▸"/>
             </a:pPr>
             <a:r>
               <a:rPr sz="1500">
                 <a:solidFill>
+                  <a:srgbClr val="1A2330"/>
+                </a:solidFill>
+                <a:latin typeface="Arial"/>
+              </a:rPr>
+              <a:t>Compute is acquired </a:t>
+            </a:r>
+            <a:r>
+              <a:rPr sz="1500" b="1">
+                <a:solidFill>
                   <a:srgbClr val="0B5FA5"/>
                 </a:solidFill>
                 <a:latin typeface="Arial"/>
               </a:rPr>
-              <a:t>▸  </a:t>
+              <a:t>on demand</a:t>
             </a:r>
             <a:r>
               <a:rPr sz="1500">
@@ -6202,45 +6176,23 @@
                 </a:solidFill>
                 <a:latin typeface="Arial"/>
               </a:rPr>
-              <a:t>Compute is acquired </a:t>
-            </a:r>
-            <a:r>
-              <a:rPr sz="1500" b="1">
-                <a:solidFill>
-                  <a:srgbClr val="0B5FA5"/>
-                </a:solidFill>
-                <a:latin typeface="Arial"/>
-              </a:rPr>
-              <a:t>on demand</a:t>
-            </a:r>
-            <a:r>
-              <a:rPr sz="1500">
-                <a:solidFill>
-                  <a:srgbClr val="1A2330"/>
-                </a:solidFill>
-                <a:latin typeface="Arial"/>
-              </a:rPr>
               <a:t>: inference and training tasks run in HPC allocations through the AmSC/RADICAL stack.</a:t>
             </a:r>
           </a:p>
           <a:p>
-            <a:pPr>
+            <a:pPr marL="256032" indent="-256032">
               <a:lnSpc>
                 <a:spcPct val="115000"/>
               </a:lnSpc>
               <a:spcAft>
                 <a:spcPts val="1000"/>
               </a:spcAft>
+              <a:buClr>
+                <a:srgbClr val="0B5FA5"/>
+              </a:buClr>
+              <a:buFont typeface="Arial"/>
+              <a:buChar char="▸"/>
             </a:pPr>
-            <a:r>
-              <a:rPr sz="1500">
-                <a:solidFill>
-                  <a:srgbClr val="0B5FA5"/>
-                </a:solidFill>
-                <a:latin typeface="Arial"/>
-              </a:rPr>
-              <a:t>▸  </a:t>
-            </a:r>
             <a:r>
               <a:rPr sz="1500">
                 <a:solidFill>
@@ -6743,35 +6695,31 @@
           </a:bodyPr>
           <a:lstStyle/>
           <a:p>
-            <a:pPr>
+            <a:pPr marL="256032" indent="-256032">
               <a:lnSpc>
                 <a:spcPct val="115000"/>
               </a:lnSpc>
               <a:spcAft>
                 <a:spcPts val="1000"/>
               </a:spcAft>
+              <a:buClr>
+                <a:srgbClr val="0B5FA5"/>
+              </a:buClr>
+              <a:buFont typeface="Arial"/>
+              <a:buChar char="▸"/>
             </a:pPr>
             <a:r>
+              <a:rPr sz="1600" b="1">
+                <a:solidFill>
+                  <a:srgbClr val="0B5FA5"/>
+                </a:solidFill>
+                <a:latin typeface="Arial"/>
+              </a:rPr>
+              <a:t>DTaaS v1 is implemented</a:t>
+            </a:r>
+            <a:r>
               <a:rPr sz="1600">
                 <a:solidFill>
-                  <a:srgbClr val="0B5FA5"/>
-                </a:solidFill>
-                <a:latin typeface="Arial"/>
-              </a:rPr>
-              <a:t>▸  </a:t>
-            </a:r>
-            <a:r>
-              <a:rPr sz="1600" b="1">
-                <a:solidFill>
-                  <a:srgbClr val="0B5FA5"/>
-                </a:solidFill>
-                <a:latin typeface="Arial"/>
-              </a:rPr>
-              <a:t>DTaaS v1 is implemented</a:t>
-            </a:r>
-            <a:r>
-              <a:rPr sz="1600">
-                <a:solidFill>
                   <a:srgbClr val="1A2330"/>
                 </a:solidFill>
                 <a:latin typeface="Arial"/>
@@ -6780,31 +6728,45 @@
             </a:r>
           </a:p>
           <a:p>
-            <a:pPr>
+            <a:pPr marL="256032" indent="-256032">
               <a:lnSpc>
                 <a:spcPct val="115000"/>
               </a:lnSpc>
               <a:spcAft>
                 <a:spcPts val="1000"/>
               </a:spcAft>
+              <a:buClr>
+                <a:srgbClr val="0B5FA5"/>
+              </a:buClr>
+              <a:buFont typeface="Arial"/>
+              <a:buChar char="▸"/>
             </a:pPr>
             <a:r>
+              <a:rPr sz="1600" b="1">
+                <a:solidFill>
+                  <a:srgbClr val="0B5FA5"/>
+                </a:solidFill>
+                <a:latin typeface="Arial"/>
+              </a:rPr>
+              <a:t>126 tests</a:t>
+            </a:r>
+            <a:r>
               <a:rPr sz="1600">
                 <a:solidFill>
-                  <a:srgbClr val="0B5FA5"/>
-                </a:solidFill>
-                <a:latin typeface="Arial"/>
-              </a:rPr>
-              <a:t>▸  </a:t>
+                  <a:srgbClr val="1A2330"/>
+                </a:solidFill>
+                <a:latin typeface="Arial"/>
+              </a:rPr>
+              <a:t>, including live-broker integration; demos run end to end and </a:t>
             </a:r>
             <a:r>
               <a:rPr sz="1600" b="1">
                 <a:solidFill>
-                  <a:srgbClr val="0B5FA5"/>
-                </a:solidFill>
-                <a:latin typeface="Arial"/>
-              </a:rPr>
-              <a:t>126 tests</a:t>
+                  <a:srgbClr val="B3541E"/>
+                </a:solidFill>
+                <a:latin typeface="Arial"/>
+              </a:rPr>
+              <a:t>calibration converges</a:t>
             </a:r>
             <a:r>
               <a:rPr sz="1600">
@@ -6813,44 +6775,40 @@
                 </a:solidFill>
                 <a:latin typeface="Arial"/>
               </a:rPr>
-              <a:t>, including live-broker integration; demos run end to end and </a:t>
-            </a:r>
-            <a:r>
-              <a:rPr sz="1600" b="1">
-                <a:solidFill>
-                  <a:srgbClr val="B3541E"/>
-                </a:solidFill>
-                <a:latin typeface="Arial"/>
-              </a:rPr>
-              <a:t>calibration converges</a:t>
-            </a:r>
-            <a:r>
-              <a:rPr sz="1600">
-                <a:solidFill>
-                  <a:srgbClr val="1A2330"/>
-                </a:solidFill>
-                <a:latin typeface="Arial"/>
-              </a:rPr>
               <a:t>.</a:t>
             </a:r>
           </a:p>
           <a:p>
-            <a:pPr>
+            <a:pPr marL="256032" indent="-256032">
               <a:lnSpc>
                 <a:spcPct val="115000"/>
               </a:lnSpc>
               <a:spcAft>
                 <a:spcPts val="1000"/>
               </a:spcAft>
+              <a:buClr>
+                <a:srgbClr val="0B5FA5"/>
+              </a:buClr>
+              <a:buFont typeface="Arial"/>
+              <a:buChar char="▸"/>
             </a:pPr>
             <a:r>
               <a:rPr sz="1600">
                 <a:solidFill>
+                  <a:srgbClr val="1A2330"/>
+                </a:solidFill>
+                <a:latin typeface="Arial"/>
+              </a:rPr>
+              <a:t>Latencies are </a:t>
+            </a:r>
+            <a:r>
+              <a:rPr sz="1600" b="1">
+                <a:solidFill>
                   <a:srgbClr val="0B5FA5"/>
                 </a:solidFill>
                 <a:latin typeface="Arial"/>
               </a:rPr>
-              <a:t>▸  </a:t>
+              <a:t>measured</a:t>
             </a:r>
             <a:r>
               <a:rPr sz="1600">
@@ -6859,45 +6817,23 @@
                 </a:solidFill>
                 <a:latin typeface="Arial"/>
               </a:rPr>
-              <a:t>Latencies are </a:t>
-            </a:r>
-            <a:r>
-              <a:rPr sz="1600" b="1">
-                <a:solidFill>
-                  <a:srgbClr val="0B5FA5"/>
-                </a:solidFill>
-                <a:latin typeface="Arial"/>
-              </a:rPr>
-              <a:t>measured</a:t>
-            </a:r>
-            <a:r>
-              <a:rPr sz="1600">
-                <a:solidFill>
-                  <a:srgbClr val="1A2330"/>
-                </a:solidFill>
-                <a:latin typeface="Arial"/>
-              </a:rPr>
               <a:t>: ~20 ms per served prediction, 1–2 ms per stream hop.</a:t>
             </a:r>
           </a:p>
           <a:p>
-            <a:pPr>
+            <a:pPr marL="256032" indent="-256032">
               <a:lnSpc>
                 <a:spcPct val="115000"/>
               </a:lnSpc>
               <a:spcAft>
                 <a:spcPts val="1000"/>
               </a:spcAft>
+              <a:buClr>
+                <a:srgbClr val="0B5FA5"/>
+              </a:buClr>
+              <a:buFont typeface="Arial"/>
+              <a:buChar char="▸"/>
             </a:pPr>
-            <a:r>
-              <a:rPr sz="1600">
-                <a:solidFill>
-                  <a:srgbClr val="0B5FA5"/>
-                </a:solidFill>
-                <a:latin typeface="Arial"/>
-              </a:rPr>
-              <a:t>▸  </a:t>
-            </a:r>
             <a:r>
               <a:rPr sz="1600">
                 <a:solidFill>
@@ -7149,22 +7085,36 @@
           </a:bodyPr>
           <a:lstStyle/>
           <a:p>
-            <a:pPr>
+            <a:pPr marL="256032" indent="-256032">
               <a:lnSpc>
                 <a:spcPct val="115000"/>
               </a:lnSpc>
               <a:spcAft>
                 <a:spcPts val="1000"/>
               </a:spcAft>
+              <a:buClr>
+                <a:srgbClr val="0B5FA5"/>
+              </a:buClr>
+              <a:buFont typeface="Arial"/>
+              <a:buChar char="▸"/>
             </a:pPr>
             <a:r>
               <a:rPr sz="1500">
                 <a:solidFill>
+                  <a:srgbClr val="1A2330"/>
+                </a:solidFill>
+                <a:latin typeface="Arial"/>
+              </a:rPr>
+              <a:t>A surrogate on NSTX-U geometry </a:t>
+            </a:r>
+            <a:r>
+              <a:rPr sz="1500" b="1">
+                <a:solidFill>
                   <a:srgbClr val="0B5FA5"/>
                 </a:solidFill>
                 <a:latin typeface="Arial"/>
               </a:rPr>
-              <a:t>▸  </a:t>
+              <a:t>has been demonstrated on this stack</a:t>
             </a:r>
             <a:r>
               <a:rPr sz="1500">
@@ -7173,44 +7123,40 @@
                 </a:solidFill>
                 <a:latin typeface="Arial"/>
               </a:rPr>
-              <a:t>A surrogate on NSTX-U geometry </a:t>
-            </a:r>
-            <a:r>
-              <a:rPr sz="1500" b="1">
-                <a:solidFill>
-                  <a:srgbClr val="0B5FA5"/>
-                </a:solidFill>
-                <a:latin typeface="Arial"/>
-              </a:rPr>
-              <a:t>has been demonstrated on this stack</a:t>
-            </a:r>
-            <a:r>
-              <a:rPr sz="1500">
-                <a:solidFill>
-                  <a:srgbClr val="1A2330"/>
-                </a:solidFill>
-                <a:latin typeface="Arial"/>
-              </a:rPr>
               <a:t>: the heat recipe learns the Eich optical heat flux with active learning on Perlmutter.</a:t>
             </a:r>
           </a:p>
           <a:p>
-            <a:pPr>
+            <a:pPr marL="256032" indent="-256032">
               <a:lnSpc>
                 <a:spcPct val="115000"/>
               </a:lnSpc>
               <a:spcAft>
                 <a:spcPts val="1000"/>
               </a:spcAft>
+              <a:buClr>
+                <a:srgbClr val="0B5FA5"/>
+              </a:buClr>
+              <a:buFont typeface="Arial"/>
+              <a:buChar char="▸"/>
             </a:pPr>
             <a:r>
               <a:rPr sz="1500">
                 <a:solidFill>
+                  <a:srgbClr val="1A2330"/>
+                </a:solidFill>
+                <a:latin typeface="Arial"/>
+              </a:rPr>
+              <a:t>No standing service is required: the compute side is </a:t>
+            </a:r>
+            <a:r>
+              <a:rPr sz="1500" b="1">
+                <a:solidFill>
                   <a:srgbClr val="0B5FA5"/>
                 </a:solidFill>
                 <a:latin typeface="Arial"/>
               </a:rPr>
-              <a:t>▸  </a:t>
+              <a:t>spawned on demand</a:t>
             </a:r>
             <a:r>
               <a:rPr sz="1500">
@@ -7219,44 +7165,40 @@
                 </a:solidFill>
                 <a:latin typeface="Arial"/>
               </a:rPr>
-              <a:t>No standing service is required: the compute side is </a:t>
-            </a:r>
-            <a:r>
-              <a:rPr sz="1500" b="1">
-                <a:solidFill>
-                  <a:srgbClr val="0B5FA5"/>
-                </a:solidFill>
-                <a:latin typeface="Arial"/>
-              </a:rPr>
-              <a:t>spawned on demand</a:t>
-            </a:r>
-            <a:r>
-              <a:rPr sz="1500">
-                <a:solidFill>
-                  <a:srgbClr val="1A2330"/>
-                </a:solidFill>
-                <a:latin typeface="Arial"/>
-              </a:rPr>
               <a:t> into a normal allocation and torn down after the run.</a:t>
             </a:r>
           </a:p>
           <a:p>
-            <a:pPr>
+            <a:pPr marL="256032" indent="-256032">
               <a:lnSpc>
                 <a:spcPct val="115000"/>
               </a:lnSpc>
               <a:spcAft>
                 <a:spcPts val="1000"/>
               </a:spcAft>
+              <a:buClr>
+                <a:srgbClr val="0B5FA5"/>
+              </a:buClr>
+              <a:buFont typeface="Arial"/>
+              <a:buChar char="▸"/>
             </a:pPr>
             <a:r>
               <a:rPr sz="1500">
                 <a:solidFill>
+                  <a:srgbClr val="1A2330"/>
+                </a:solidFill>
+                <a:latin typeface="Arial"/>
+              </a:rPr>
+              <a:t>Diagnostics become </a:t>
+            </a:r>
+            <a:r>
+              <a:rPr sz="1500" b="1">
+                <a:solidFill>
                   <a:srgbClr val="0B5FA5"/>
                 </a:solidFill>
                 <a:latin typeface="Arial"/>
               </a:rPr>
-              <a:t>▸  </a:t>
+              <a:t>event sources</a:t>
             </a:r>
             <a:r>
               <a:rPr sz="1500">
@@ -7265,44 +7207,40 @@
                 </a:solidFill>
                 <a:latin typeface="Arial"/>
               </a:rPr>
-              <a:t>Diagnostics become </a:t>
-            </a:r>
-            <a:r>
-              <a:rPr sz="1500" b="1">
-                <a:solidFill>
-                  <a:srgbClr val="0B5FA5"/>
-                </a:solidFill>
-                <a:latin typeface="Arial"/>
-              </a:rPr>
-              <a:t>event sources</a:t>
-            </a:r>
-            <a:r>
-              <a:rPr sz="1500">
-                <a:solidFill>
-                  <a:srgbClr val="1A2330"/>
-                </a:solidFill>
-                <a:latin typeface="Arial"/>
-              </a:rPr>
               <a:t>: any stream feeds the DT, live or from shot archives.</a:t>
             </a:r>
           </a:p>
           <a:p>
-            <a:pPr>
+            <a:pPr marL="256032" indent="-256032">
               <a:lnSpc>
                 <a:spcPct val="115000"/>
               </a:lnSpc>
               <a:spcAft>
                 <a:spcPts val="1000"/>
               </a:spcAft>
+              <a:buClr>
+                <a:srgbClr val="0B5FA5"/>
+              </a:buClr>
+              <a:buFont typeface="Arial"/>
+              <a:buChar char="▸"/>
             </a:pPr>
             <a:r>
               <a:rPr sz="1500">
                 <a:solidFill>
+                  <a:srgbClr val="1A2330"/>
+                </a:solidFill>
+                <a:latin typeface="Arial"/>
+              </a:rPr>
+              <a:t>Models </a:t>
+            </a:r>
+            <a:r>
+              <a:rPr sz="1500" b="1">
+                <a:solidFill>
                   <a:srgbClr val="0B5FA5"/>
                 </a:solidFill>
                 <a:latin typeface="Arial"/>
               </a:rPr>
-              <a:t>▸  </a:t>
+              <a:t>learn between shots</a:t>
             </a:r>
             <a:r>
               <a:rPr sz="1500">
@@ -7311,7 +7249,7 @@
                 </a:solidFill>
                 <a:latin typeface="Arial"/>
               </a:rPr>
-              <a:t>Models </a:t>
+              <a:t> and </a:t>
             </a:r>
             <a:r>
               <a:rPr sz="1500" b="1">
@@ -7320,7 +7258,7 @@
                 </a:solidFill>
                 <a:latin typeface="Arial"/>
               </a:rPr>
-              <a:t>learn between shots</a:t>
+              <a:t>serve between and during shots</a:t>
             </a:r>
             <a:r>
               <a:rPr sz="1500">
@@ -7329,44 +7267,40 @@
                 </a:solidFill>
                 <a:latin typeface="Arial"/>
               </a:rPr>
-              <a:t> and </a:t>
-            </a:r>
-            <a:r>
-              <a:rPr sz="1500" b="1">
-                <a:solidFill>
-                  <a:srgbClr val="0B5FA5"/>
-                </a:solidFill>
-                <a:latin typeface="Arial"/>
-              </a:rPr>
-              <a:t>serve between and during shots</a:t>
-            </a:r>
-            <a:r>
-              <a:rPr sz="1500">
-                <a:solidFill>
-                  <a:srgbClr val="1A2330"/>
-                </a:solidFill>
-                <a:latin typeface="Arial"/>
-              </a:rPr>
               <a:t>; they improve continuously as data arrives.</a:t>
             </a:r>
           </a:p>
           <a:p>
-            <a:pPr>
+            <a:pPr marL="256032" indent="-256032">
               <a:lnSpc>
                 <a:spcPct val="115000"/>
               </a:lnSpc>
               <a:spcAft>
                 <a:spcPts val="1000"/>
               </a:spcAft>
+              <a:buClr>
+                <a:srgbClr val="0B5FA5"/>
+              </a:buClr>
+              <a:buFont typeface="Arial"/>
+              <a:buChar char="▸"/>
             </a:pPr>
             <a:r>
               <a:rPr sz="1500">
                 <a:solidFill>
-                  <a:srgbClr val="0B5FA5"/>
-                </a:solidFill>
-                <a:latin typeface="Arial"/>
-              </a:rPr>
-              <a:t>▸  </a:t>
+                  <a:srgbClr val="1A2330"/>
+                </a:solidFill>
+                <a:latin typeface="Arial"/>
+              </a:rPr>
+              <a:t>Compute runs on DOE HPC; PPPL deploys </a:t>
+            </a:r>
+            <a:r>
+              <a:rPr sz="1500" b="1">
+                <a:solidFill>
+                  <a:srgbClr val="B3541E"/>
+                </a:solidFill>
+                <a:latin typeface="Arial"/>
+              </a:rPr>
+              <a:t>no services</a:t>
             </a:r>
             <a:r>
               <a:rPr sz="1500">
@@ -7375,7 +7309,7 @@
                 </a:solidFill>
                 <a:latin typeface="Arial"/>
               </a:rPr>
-              <a:t>Compute runs on DOE HPC; PPPL deploys </a:t>
+              <a:t> and opens </a:t>
             </a:r>
             <a:r>
               <a:rPr sz="1500" b="1">
@@ -7384,7 +7318,7 @@
                 </a:solidFill>
                 <a:latin typeface="Arial"/>
               </a:rPr>
-              <a:t>no services</a:t>
+              <a:t>no inbound ports</a:t>
             </a:r>
             <a:r>
               <a:rPr sz="1500">
@@ -7393,45 +7327,23 @@
                 </a:solidFill>
                 <a:latin typeface="Arial"/>
               </a:rPr>
-              <a:t> and opens </a:t>
-            </a:r>
-            <a:r>
-              <a:rPr sz="1500" b="1">
-                <a:solidFill>
-                  <a:srgbClr val="B3541E"/>
-                </a:solidFill>
-                <a:latin typeface="Arial"/>
-              </a:rPr>
-              <a:t>no inbound ports</a:t>
-            </a:r>
-            <a:r>
-              <a:rPr sz="1500">
-                <a:solidFill>
-                  <a:srgbClr val="1A2330"/>
-                </a:solidFill>
-                <a:latin typeface="Arial"/>
-              </a:rPr>
               <a:t>.</a:t>
             </a:r>
           </a:p>
           <a:p>
-            <a:pPr>
+            <a:pPr marL="256032" indent="-256032">
               <a:lnSpc>
                 <a:spcPct val="115000"/>
               </a:lnSpc>
               <a:spcAft>
                 <a:spcPts val="1000"/>
               </a:spcAft>
+              <a:buClr>
+                <a:srgbClr val="0B5FA5"/>
+              </a:buClr>
+              <a:buFont typeface="Arial"/>
+              <a:buChar char="▸"/>
             </a:pPr>
-            <a:r>
-              <a:rPr sz="1500">
-                <a:solidFill>
-                  <a:srgbClr val="0B5FA5"/>
-                </a:solidFill>
-                <a:latin typeface="Arial"/>
-              </a:rPr>
-              <a:t>▸  </a:t>
-            </a:r>
             <a:r>
               <a:rPr sz="1500">
                 <a:solidFill>
@@ -7631,26 +7543,22 @@
           </a:bodyPr>
           <a:lstStyle/>
           <a:p>
-            <a:pPr>
+            <a:pPr marL="256032" indent="-256032">
               <a:lnSpc>
                 <a:spcPct val="115000"/>
               </a:lnSpc>
               <a:spcAft>
                 <a:spcPts val="1000"/>
               </a:spcAft>
+              <a:buClr>
+                <a:srgbClr val="0B5FA5"/>
+              </a:buClr>
+              <a:buFont typeface="Arial"/>
+              <a:buChar char="▸"/>
             </a:pPr>
             <a:r>
               <a:rPr sz="1500">
                 <a:solidFill>
-                  <a:srgbClr val="0B5FA5"/>
-                </a:solidFill>
-                <a:latin typeface="Arial"/>
-              </a:rPr>
-              <a:t>▸  </a:t>
-            </a:r>
-            <a:r>
-              <a:rPr sz="1500">
-                <a:solidFill>
                   <a:srgbClr val="1A2330"/>
                 </a:solidFill>
                 <a:latin typeface="Arial"/>
@@ -7659,35 +7567,31 @@
             </a:r>
           </a:p>
           <a:p>
-            <a:pPr>
+            <a:pPr marL="256032" indent="-256032">
               <a:lnSpc>
                 <a:spcPct val="115000"/>
               </a:lnSpc>
               <a:spcAft>
                 <a:spcPts val="1000"/>
               </a:spcAft>
+              <a:buClr>
+                <a:srgbClr val="0B5FA5"/>
+              </a:buClr>
+              <a:buFont typeface="Arial"/>
+              <a:buChar char="▸"/>
             </a:pPr>
             <a:r>
+              <a:rPr sz="1500" b="1">
+                <a:solidFill>
+                  <a:srgbClr val="0B5FA5"/>
+                </a:solidFill>
+                <a:latin typeface="Arial"/>
+              </a:rPr>
+              <a:t>Meaning</a:t>
+            </a:r>
+            <a:r>
               <a:rPr sz="1500">
                 <a:solidFill>
-                  <a:srgbClr val="0B5FA5"/>
-                </a:solidFill>
-                <a:latin typeface="Arial"/>
-              </a:rPr>
-              <a:t>▸  </a:t>
-            </a:r>
-            <a:r>
-              <a:rPr sz="1500" b="1">
-                <a:solidFill>
-                  <a:srgbClr val="0B5FA5"/>
-                </a:solidFill>
-                <a:latin typeface="Arial"/>
-              </a:rPr>
-              <a:t>Meaning</a:t>
-            </a:r>
-            <a:r>
-              <a:rPr sz="1500">
-                <a:solidFill>
                   <a:srgbClr val="1A2330"/>
                 </a:solidFill>
                 <a:latin typeface="Arial"/>
@@ -7696,35 +7600,31 @@
             </a:r>
           </a:p>
           <a:p>
-            <a:pPr>
+            <a:pPr marL="256032" indent="-256032">
               <a:lnSpc>
                 <a:spcPct val="115000"/>
               </a:lnSpc>
               <a:spcAft>
                 <a:spcPts val="1000"/>
               </a:spcAft>
+              <a:buClr>
+                <a:srgbClr val="0B5FA5"/>
+              </a:buClr>
+              <a:buFont typeface="Arial"/>
+              <a:buChar char="▸"/>
             </a:pPr>
             <a:r>
+              <a:rPr sz="1500" b="1">
+                <a:solidFill>
+                  <a:srgbClr val="0B5FA5"/>
+                </a:solidFill>
+                <a:latin typeface="Arial"/>
+              </a:rPr>
+              <a:t>Signals</a:t>
+            </a:r>
+            <a:r>
               <a:rPr sz="1500">
                 <a:solidFill>
-                  <a:srgbClr val="0B5FA5"/>
-                </a:solidFill>
-                <a:latin typeface="Arial"/>
-              </a:rPr>
-              <a:t>▸  </a:t>
-            </a:r>
-            <a:r>
-              <a:rPr sz="1500" b="1">
-                <a:solidFill>
-                  <a:srgbClr val="0B5FA5"/>
-                </a:solidFill>
-                <a:latin typeface="Arial"/>
-              </a:rPr>
-              <a:t>Signals</a:t>
-            </a:r>
-            <a:r>
-              <a:rPr sz="1500">
-                <a:solidFill>
                   <a:srgbClr val="1A2330"/>
                 </a:solidFill>
                 <a:latin typeface="Arial"/>
@@ -7733,35 +7633,31 @@
             </a:r>
           </a:p>
           <a:p>
-            <a:pPr>
+            <a:pPr marL="256032" indent="-256032">
               <a:lnSpc>
                 <a:spcPct val="115000"/>
               </a:lnSpc>
               <a:spcAft>
                 <a:spcPts val="1000"/>
               </a:spcAft>
+              <a:buClr>
+                <a:srgbClr val="0B5FA5"/>
+              </a:buClr>
+              <a:buFont typeface="Arial"/>
+              <a:buChar char="▸"/>
             </a:pPr>
             <a:r>
+              <a:rPr sz="1500" b="1">
+                <a:solidFill>
+                  <a:srgbClr val="0B5FA5"/>
+                </a:solidFill>
+                <a:latin typeface="Arial"/>
+              </a:rPr>
+              <a:t>Data</a:t>
+            </a:r>
+            <a:r>
               <a:rPr sz="1500">
                 <a:solidFill>
-                  <a:srgbClr val="0B5FA5"/>
-                </a:solidFill>
-                <a:latin typeface="Arial"/>
-              </a:rPr>
-              <a:t>▸  </a:t>
-            </a:r>
-            <a:r>
-              <a:rPr sz="1500" b="1">
-                <a:solidFill>
-                  <a:srgbClr val="0B5FA5"/>
-                </a:solidFill>
-                <a:latin typeface="Arial"/>
-              </a:rPr>
-              <a:t>Data</a:t>
-            </a:r>
-            <a:r>
-              <a:rPr sz="1500">
-                <a:solidFill>
                   <a:srgbClr val="1A2330"/>
                 </a:solidFill>
                 <a:latin typeface="Arial"/>
@@ -7770,35 +7666,31 @@
             </a:r>
           </a:p>
           <a:p>
-            <a:pPr>
+            <a:pPr marL="256032" indent="-256032">
               <a:lnSpc>
                 <a:spcPct val="115000"/>
               </a:lnSpc>
               <a:spcAft>
                 <a:spcPts val="1000"/>
               </a:spcAft>
+              <a:buClr>
+                <a:srgbClr val="0B5FA5"/>
+              </a:buClr>
+              <a:buFont typeface="Arial"/>
+              <a:buChar char="▸"/>
             </a:pPr>
             <a:r>
+              <a:rPr sz="1500" b="1">
+                <a:solidFill>
+                  <a:srgbClr val="0B5FA5"/>
+                </a:solidFill>
+                <a:latin typeface="Arial"/>
+              </a:rPr>
+              <a:t>Placement and latency</a:t>
+            </a:r>
+            <a:r>
               <a:rPr sz="1500">
                 <a:solidFill>
-                  <a:srgbClr val="0B5FA5"/>
-                </a:solidFill>
-                <a:latin typeface="Arial"/>
-              </a:rPr>
-              <a:t>▸  </a:t>
-            </a:r>
-            <a:r>
-              <a:rPr sz="1500" b="1">
-                <a:solidFill>
-                  <a:srgbClr val="0B5FA5"/>
-                </a:solidFill>
-                <a:latin typeface="Arial"/>
-              </a:rPr>
-              <a:t>Placement and latency</a:t>
-            </a:r>
-            <a:r>
-              <a:rPr sz="1500">
-                <a:solidFill>
                   <a:srgbClr val="1A2330"/>
                 </a:solidFill>
                 <a:latin typeface="Arial"/>
@@ -7807,23 +7699,19 @@
             </a:r>
           </a:p>
           <a:p>
-            <a:pPr>
+            <a:pPr marL="256032" indent="-256032">
               <a:lnSpc>
                 <a:spcPct val="115000"/>
               </a:lnSpc>
               <a:spcAft>
                 <a:spcPts val="1000"/>
               </a:spcAft>
+              <a:buClr>
+                <a:srgbClr val="0B5FA5"/>
+              </a:buClr>
+              <a:buFont typeface="Arial"/>
+              <a:buChar char="▸"/>
             </a:pPr>
-            <a:r>
-              <a:rPr sz="1500">
-                <a:solidFill>
-                  <a:srgbClr val="0B5FA5"/>
-                </a:solidFill>
-                <a:latin typeface="Arial"/>
-              </a:rPr>
-              <a:t>▸  </a:t>
-            </a:r>
             <a:r>
               <a:rPr sz="1500" b="1">
                 <a:solidFill>
@@ -8066,26 +7954,22 @@
           </a:bodyPr>
           <a:lstStyle/>
           <a:p>
-            <a:pPr>
+            <a:pPr marL="256032" indent="-256032">
               <a:lnSpc>
                 <a:spcPct val="115000"/>
               </a:lnSpc>
               <a:spcAft>
                 <a:spcPts val="1000"/>
               </a:spcAft>
+              <a:buClr>
+                <a:srgbClr val="0B5FA5"/>
+              </a:buClr>
+              <a:buFont typeface="Arial"/>
+              <a:buChar char="▸"/>
             </a:pPr>
             <a:r>
               <a:rPr sz="1700">
                 <a:solidFill>
-                  <a:srgbClr val="0B5FA5"/>
-                </a:solidFill>
-                <a:latin typeface="Arial"/>
-              </a:rPr>
-              <a:t>▸  </a:t>
-            </a:r>
-            <a:r>
-              <a:rPr sz="1700">
-                <a:solidFill>
                   <a:srgbClr val="1A2330"/>
                 </a:solidFill>
                 <a:latin typeface="Arial"/>
@@ -8094,26 +7978,22 @@
             </a:r>
           </a:p>
           <a:p>
-            <a:pPr>
+            <a:pPr marL="256032" indent="-256032">
               <a:lnSpc>
                 <a:spcPct val="115000"/>
               </a:lnSpc>
               <a:spcAft>
                 <a:spcPts val="1000"/>
               </a:spcAft>
+              <a:buClr>
+                <a:srgbClr val="0B5FA5"/>
+              </a:buClr>
+              <a:buFont typeface="Arial"/>
+              <a:buChar char="▸"/>
             </a:pPr>
             <a:r>
               <a:rPr sz="1700">
                 <a:solidFill>
-                  <a:srgbClr val="0B5FA5"/>
-                </a:solidFill>
-                <a:latin typeface="Arial"/>
-              </a:rPr>
-              <a:t>▸  </a:t>
-            </a:r>
-            <a:r>
-              <a:rPr sz="1700">
-                <a:solidFill>
                   <a:srgbClr val="1A2330"/>
                 </a:solidFill>
                 <a:latin typeface="Arial"/>
@@ -8122,23 +8002,19 @@
             </a:r>
           </a:p>
           <a:p>
-            <a:pPr>
+            <a:pPr marL="256032" indent="-256032">
               <a:lnSpc>
                 <a:spcPct val="115000"/>
               </a:lnSpc>
               <a:spcAft>
                 <a:spcPts val="1000"/>
               </a:spcAft>
+              <a:buClr>
+                <a:srgbClr val="0B5FA5"/>
+              </a:buClr>
+              <a:buFont typeface="Arial"/>
+              <a:buChar char="▸"/>
             </a:pPr>
-            <a:r>
-              <a:rPr sz="1700">
-                <a:solidFill>
-                  <a:srgbClr val="0B5FA5"/>
-                </a:solidFill>
-                <a:latin typeface="Arial"/>
-              </a:rPr>
-              <a:t>▸  </a:t>
-            </a:r>
             <a:r>
               <a:rPr sz="1700">
                 <a:solidFill>

</xml_diff>